<commit_message>
Refactor fraud workflow to prevention model
</commit_message>
<xml_diff>
--- a/report/final_slide_deck.pptx
+++ b/report/final_slide_deck.pptx
@@ -3511,7 +3511,7 @@
                 </a:solidFill>
                 <a:latin typeface="Arial"/>
               </a:rPr>
-              <a:t>Data -&gt; baseline -&gt; rules -&gt; Isolation Forest -&gt; SHAP/xAI -&gt; review queue.</a:t>
+              <a:t>Data -&gt; baseline -&gt; rules -&gt; weak labels -&gt; supervised prevention model -&gt; SHAP/xAI.</a:t>
             </a:r>
           </a:p>
         </p:txBody>
@@ -3554,7 +3554,7 @@
               </a:defRPr>
             </a:pPr>
             <a:r>
-              <a:t>60% root-cause rules + 40% anomaly score</a:t>
+              <a:t>Rule-derived weak labels train the supervised prevention model</a:t>
             </a:r>
           </a:p>
           <a:p>
@@ -3693,7 +3693,7 @@
                 </a:solidFill>
                 <a:latin typeface="Arial"/>
               </a:rPr>
-              <a:t>1,418,030 transactions scored; 35,451 High/Critical.</a:t>
+              <a:t>1,418,030 transactions scored; 182,546 High/Critical.</a:t>
             </a:r>
           </a:p>
         </p:txBody>

</xml_diff>

<commit_message>
Incorporate mentor feedback on prevention metrics
</commit_message>
<xml_diff>
--- a/report/final_slide_deck.pptx
+++ b/report/final_slide_deck.pptx
@@ -3693,7 +3693,60 @@
                 </a:solidFill>
                 <a:latin typeface="Arial"/>
               </a:rPr>
-              <a:t>1,418,030 transactions scored; 182,546 High/Critical.</a:t>
+              <a:t>1,418,030 transactions scored; 179,979 High/Critical.</a:t>
+            </a:r>
+          </a:p>
+        </p:txBody>
+      </p:sp>
+      <p:sp>
+        <p:nvSpPr>
+          <p:cNvPr id="5" name="TextBox 4"/>
+          <p:cNvSpPr txBox="1"/>
+          <p:nvPr/>
+        </p:nvSpPr>
+        <p:spPr>
+          <a:xfrm>
+            <a:off x="685800" y="1828800"/>
+            <a:ext cx="10698480" cy="3840480"/>
+          </a:xfrm>
+          <a:prstGeom prst="rect">
+            <a:avLst/>
+          </a:prstGeom>
+          <a:noFill/>
+        </p:spPr>
+        <p:txBody>
+          <a:bodyPr wrap="none">
+            <a:spAutoFit/>
+          </a:bodyPr>
+          <a:lstStyle/>
+          <a:p>
+            <a:pPr>
+              <a:defRPr sz="2100">
+                <a:latin typeface="Arial"/>
+              </a:defRPr>
+            </a:pPr>
+            <a:r>
+              <a:t>Prevention coverage vs weak labels: 90.3%</a:t>
+            </a:r>
+          </a:p>
+          <a:p>
+            <a:pPr>
+              <a:defRPr sz="2100">
+                <a:latin typeface="Arial"/>
+              </a:defRPr>
+            </a:pPr>
+            <a:r>
+              <a:t>False-positive rate at high threshold: 0.00%</a:t>
+            </a:r>
+          </a:p>
+          <a:p>
+            <a:pPr>
+              <a:defRPr sz="2100">
+                <a:latin typeface="Arial"/>
+              </a:defRPr>
+            </a:pPr>
+            <a:r>
+              <a:t>Confusion matrix and protected amount are reported for business impact, not only model accuracy.</a:t>
             </a:r>
           </a:p>
         </p:txBody>

</xml_diff>

<commit_message>
Add customer 360 hybrid fraud prevention flow
</commit_message>
<xml_diff>
--- a/report/final_slide_deck.pptx
+++ b/report/final_slide_deck.pptx
@@ -12,6 +12,8 @@
     <p:sldId id="260" r:id="rId11"/>
     <p:sldId id="261" r:id="rId12"/>
     <p:sldId id="262" r:id="rId13"/>
+    <p:sldId id="263" r:id="rId14"/>
+    <p:sldId id="264" r:id="rId15"/>
   </p:sldIdLst>
   <p:sldSz cx="12191695" cy="6858000" type="screen4x3"/>
   <p:notesSz cx="6858000" cy="9144000"/>
@@ -3544,7 +3546,7 @@
               </a:defRPr>
             </a:pPr>
             <a:r>
-              <a:t>Behavioral baseline by customer</a:t>
+              <a:t>Customer 360 baseline by Transactional, Financial, Environmental and Behavioral groups</a:t>
             </a:r>
           </a:p>
           <a:p>
@@ -3554,7 +3556,7 @@
               </a:defRPr>
             </a:pPr>
             <a:r>
-              <a:t>Rule-derived weak labels train the supervised prevention model</a:t>
+              <a:t>Rolling 30/60/90-day features plus IQR thresholds</a:t>
             </a:r>
           </a:p>
           <a:p>
@@ -3564,7 +3566,17 @@
               </a:defRPr>
             </a:pPr>
             <a:r>
-              <a:t>Human-readable reason codes and recommended actions</a:t>
+              <a:t>Rule-derived weak labels train the supervised prevention model</a:t>
+            </a:r>
+          </a:p>
+          <a:p>
+            <a:pPr>
+              <a:defRPr sz="2100">
+                <a:latin typeface="Arial"/>
+              </a:defRPr>
+            </a:pPr>
+            <a:r>
+              <a:t>Hybrid matrix creates human-readable recommended actions</a:t>
             </a:r>
           </a:p>
         </p:txBody>
@@ -3693,7 +3705,7 @@
                 </a:solidFill>
                 <a:latin typeface="Arial"/>
               </a:rPr>
-              <a:t>1,418,030 transactions scored; 179,979 High/Critical.</a:t>
+              <a:t>1,418,030 transactions scored; 402,266 High/Critical.</a:t>
             </a:r>
           </a:p>
         </p:txBody>
@@ -3726,7 +3738,7 @@
               </a:defRPr>
             </a:pPr>
             <a:r>
-              <a:t>Prevention coverage vs weak labels: 90.3%</a:t>
+              <a:t>Prevention coverage vs weak labels: 100.0%</a:t>
             </a:r>
           </a:p>
           <a:p>
@@ -3874,6 +3886,158 @@
                 </a:solidFill>
                 <a:latin typeface="Arial"/>
               </a:rPr>
+              <a:t>Customer 360 Rolling Baseline</a:t>
+            </a:r>
+          </a:p>
+        </p:txBody>
+      </p:sp>
+      <p:pic>
+        <p:nvPicPr>
+          <p:cNvPr id="3" name="Picture 2" descr="rolling_window_baseline.png"/>
+          <p:cNvPicPr>
+            <a:picLocks noChangeAspect="1"/>
+          </p:cNvPicPr>
+          <p:nvPr/>
+        </p:nvPicPr>
+        <p:blipFill>
+          <a:blip r:embed="rId2"/>
+          <a:stretch>
+            <a:fillRect/>
+          </a:stretch>
+        </p:blipFill>
+        <p:spPr>
+          <a:xfrm>
+            <a:off x="822960" y="1097280"/>
+            <a:ext cx="10515600" cy="5212080"/>
+          </a:xfrm>
+          <a:prstGeom prst="rect">
+            <a:avLst/>
+          </a:prstGeom>
+        </p:spPr>
+      </p:pic>
+    </p:spTree>
+  </p:cSld>
+  <p:clrMapOvr>
+    <a:masterClrMapping/>
+  </p:clrMapOvr>
+</p:sld>
+</file>
+
+<file path=ppt/slides/slide7.xml><?xml version="1.0" encoding="utf-8"?>
+<p:sld xmlns:a="http://schemas.openxmlformats.org/drawingml/2006/main" xmlns:p="http://schemas.openxmlformats.org/presentationml/2006/main" xmlns:r="http://schemas.openxmlformats.org/officeDocument/2006/relationships">
+  <p:cSld>
+    <p:spTree>
+      <p:nvGrpSpPr>
+        <p:cNvPr id="1" name=""/>
+        <p:cNvGrpSpPr/>
+        <p:nvPr/>
+      </p:nvGrpSpPr>
+      <p:grpSpPr/>
+      <p:sp>
+        <p:nvSpPr>
+          <p:cNvPr id="2" name="TextBox 1"/>
+          <p:cNvSpPr txBox="1"/>
+          <p:nvPr/>
+        </p:nvSpPr>
+        <p:spPr>
+          <a:xfrm>
+            <a:off x="502920" y="365760"/>
+            <a:ext cx="10972800" cy="457200"/>
+          </a:xfrm>
+          <a:prstGeom prst="rect">
+            <a:avLst/>
+          </a:prstGeom>
+          <a:noFill/>
+        </p:spPr>
+        <p:txBody>
+          <a:bodyPr wrap="none">
+            <a:spAutoFit/>
+          </a:bodyPr>
+          <a:lstStyle/>
+          <a:p>
+            <a:r>
+              <a:rPr sz="2800" b="1">
+                <a:solidFill>
+                  <a:srgbClr val="1F2933"/>
+                </a:solidFill>
+                <a:latin typeface="Arial"/>
+              </a:rPr>
+              <a:t>Hybrid Decision Matrix</a:t>
+            </a:r>
+          </a:p>
+        </p:txBody>
+      </p:sp>
+      <p:pic>
+        <p:nvPicPr>
+          <p:cNvPr id="3" name="Picture 2" descr="hybrid_decision_matrix.png"/>
+          <p:cNvPicPr>
+            <a:picLocks noChangeAspect="1"/>
+          </p:cNvPicPr>
+          <p:nvPr/>
+        </p:nvPicPr>
+        <p:blipFill>
+          <a:blip r:embed="rId2"/>
+          <a:stretch>
+            <a:fillRect/>
+          </a:stretch>
+        </p:blipFill>
+        <p:spPr>
+          <a:xfrm>
+            <a:off x="822960" y="1097280"/>
+            <a:ext cx="10515600" cy="5212080"/>
+          </a:xfrm>
+          <a:prstGeom prst="rect">
+            <a:avLst/>
+          </a:prstGeom>
+        </p:spPr>
+      </p:pic>
+    </p:spTree>
+  </p:cSld>
+  <p:clrMapOvr>
+    <a:masterClrMapping/>
+  </p:clrMapOvr>
+</p:sld>
+</file>
+
+<file path=ppt/slides/slide8.xml><?xml version="1.0" encoding="utf-8"?>
+<p:sld xmlns:a="http://schemas.openxmlformats.org/drawingml/2006/main" xmlns:p="http://schemas.openxmlformats.org/presentationml/2006/main" xmlns:r="http://schemas.openxmlformats.org/officeDocument/2006/relationships">
+  <p:cSld>
+    <p:spTree>
+      <p:nvGrpSpPr>
+        <p:cNvPr id="1" name=""/>
+        <p:cNvGrpSpPr/>
+        <p:nvPr/>
+      </p:nvGrpSpPr>
+      <p:grpSpPr/>
+      <p:sp>
+        <p:nvSpPr>
+          <p:cNvPr id="2" name="TextBox 1"/>
+          <p:cNvSpPr txBox="1"/>
+          <p:nvPr/>
+        </p:nvSpPr>
+        <p:spPr>
+          <a:xfrm>
+            <a:off x="502920" y="365760"/>
+            <a:ext cx="10972800" cy="457200"/>
+          </a:xfrm>
+          <a:prstGeom prst="rect">
+            <a:avLst/>
+          </a:prstGeom>
+          <a:noFill/>
+        </p:spPr>
+        <p:txBody>
+          <a:bodyPr wrap="none">
+            <a:spAutoFit/>
+          </a:bodyPr>
+          <a:lstStyle/>
+          <a:p>
+            <a:r>
+              <a:rPr sz="2800" b="1">
+                <a:solidFill>
+                  <a:srgbClr val="1F2933"/>
+                </a:solidFill>
+                <a:latin typeface="Arial"/>
+              </a:rPr>
               <a:t>Temporal Stability</a:t>
             </a:r>
           </a:p>
@@ -3911,7 +4075,7 @@
 </p:sld>
 </file>
 
-<file path=ppt/slides/slide7.xml><?xml version="1.0" encoding="utf-8"?>
+<file path=ppt/slides/slide9.xml><?xml version="1.0" encoding="utf-8"?>
 <p:sld xmlns:a="http://schemas.openxmlformats.org/drawingml/2006/main" xmlns:p="http://schemas.openxmlformats.org/presentationml/2006/main" xmlns:r="http://schemas.openxmlformats.org/officeDocument/2006/relationships">
   <p:cSld>
     <p:spTree>

</xml_diff>

<commit_message>
Align fraud prevention flow with mentor feedback
</commit_message>
<xml_diff>
--- a/report/final_slide_deck.pptx
+++ b/report/final_slide_deck.pptx
@@ -14,6 +14,11 @@
     <p:sldId id="262" r:id="rId13"/>
     <p:sldId id="263" r:id="rId14"/>
     <p:sldId id="264" r:id="rId15"/>
+    <p:sldId id="265" r:id="rId16"/>
+    <p:sldId id="266" r:id="rId17"/>
+    <p:sldId id="267" r:id="rId18"/>
+    <p:sldId id="268" r:id="rId19"/>
+    <p:sldId id="269" r:id="rId20"/>
   </p:sldIdLst>
   <p:sldSz cx="12191695" cy="6858000" type="screen4x3"/>
   <p:notesSz cx="6858000" cy="9144000"/>
@@ -3215,6 +3220,386 @@
 </p:sld>
 </file>
 
+<file path=ppt/slides/slide10.xml><?xml version="1.0" encoding="utf-8"?>
+<p:sld xmlns:a="http://schemas.openxmlformats.org/drawingml/2006/main" xmlns:p="http://schemas.openxmlformats.org/presentationml/2006/main" xmlns:r="http://schemas.openxmlformats.org/officeDocument/2006/relationships">
+  <p:cSld>
+    <p:spTree>
+      <p:nvGrpSpPr>
+        <p:cNvPr id="1" name=""/>
+        <p:cNvGrpSpPr/>
+        <p:nvPr/>
+      </p:nvGrpSpPr>
+      <p:grpSpPr/>
+      <p:sp>
+        <p:nvSpPr>
+          <p:cNvPr id="2" name="TextBox 1"/>
+          <p:cNvSpPr txBox="1"/>
+          <p:nvPr/>
+        </p:nvSpPr>
+        <p:spPr>
+          <a:xfrm>
+            <a:off x="502920" y="365760"/>
+            <a:ext cx="10972800" cy="457200"/>
+          </a:xfrm>
+          <a:prstGeom prst="rect">
+            <a:avLst/>
+          </a:prstGeom>
+          <a:noFill/>
+        </p:spPr>
+        <p:txBody>
+          <a:bodyPr wrap="none">
+            <a:spAutoFit/>
+          </a:bodyPr>
+          <a:lstStyle/>
+          <a:p>
+            <a:r>
+              <a:rPr sz="2800" b="1">
+                <a:solidFill>
+                  <a:srgbClr val="1F2933"/>
+                </a:solidFill>
+                <a:latin typeface="Arial"/>
+              </a:rPr>
+              <a:t>Customer 360 Risk Map</a:t>
+            </a:r>
+          </a:p>
+        </p:txBody>
+      </p:sp>
+      <p:pic>
+        <p:nvPicPr>
+          <p:cNvPr id="3" name="Picture 2" descr="customer360_risk_heatmap.png"/>
+          <p:cNvPicPr>
+            <a:picLocks noChangeAspect="1"/>
+          </p:cNvPicPr>
+          <p:nvPr/>
+        </p:nvPicPr>
+        <p:blipFill>
+          <a:blip r:embed="rId2"/>
+          <a:stretch>
+            <a:fillRect/>
+          </a:stretch>
+        </p:blipFill>
+        <p:spPr>
+          <a:xfrm>
+            <a:off x="822960" y="1097280"/>
+            <a:ext cx="10515600" cy="5212080"/>
+          </a:xfrm>
+          <a:prstGeom prst="rect">
+            <a:avLst/>
+          </a:prstGeom>
+        </p:spPr>
+      </p:pic>
+    </p:spTree>
+  </p:cSld>
+  <p:clrMapOvr>
+    <a:masterClrMapping/>
+  </p:clrMapOvr>
+</p:sld>
+</file>
+
+<file path=ppt/slides/slide11.xml><?xml version="1.0" encoding="utf-8"?>
+<p:sld xmlns:a="http://schemas.openxmlformats.org/drawingml/2006/main" xmlns:p="http://schemas.openxmlformats.org/presentationml/2006/main" xmlns:r="http://schemas.openxmlformats.org/officeDocument/2006/relationships">
+  <p:cSld>
+    <p:spTree>
+      <p:nvGrpSpPr>
+        <p:cNvPr id="1" name=""/>
+        <p:cNvGrpSpPr/>
+        <p:nvPr/>
+      </p:nvGrpSpPr>
+      <p:grpSpPr/>
+      <p:sp>
+        <p:nvSpPr>
+          <p:cNvPr id="2" name="TextBox 1"/>
+          <p:cNvSpPr txBox="1"/>
+          <p:nvPr/>
+        </p:nvSpPr>
+        <p:spPr>
+          <a:xfrm>
+            <a:off x="502920" y="365760"/>
+            <a:ext cx="10972800" cy="457200"/>
+          </a:xfrm>
+          <a:prstGeom prst="rect">
+            <a:avLst/>
+          </a:prstGeom>
+          <a:noFill/>
+        </p:spPr>
+        <p:txBody>
+          <a:bodyPr wrap="none">
+            <a:spAutoFit/>
+          </a:bodyPr>
+          <a:lstStyle/>
+          <a:p>
+            <a:r>
+              <a:rPr sz="2800" b="1">
+                <a:solidFill>
+                  <a:srgbClr val="1F2933"/>
+                </a:solidFill>
+                <a:latin typeface="Arial"/>
+              </a:rPr>
+              <a:t>Customer 360 Rolling Baseline</a:t>
+            </a:r>
+          </a:p>
+        </p:txBody>
+      </p:sp>
+      <p:pic>
+        <p:nvPicPr>
+          <p:cNvPr id="3" name="Picture 2" descr="rolling_window_baseline.png"/>
+          <p:cNvPicPr>
+            <a:picLocks noChangeAspect="1"/>
+          </p:cNvPicPr>
+          <p:nvPr/>
+        </p:nvPicPr>
+        <p:blipFill>
+          <a:blip r:embed="rId2"/>
+          <a:stretch>
+            <a:fillRect/>
+          </a:stretch>
+        </p:blipFill>
+        <p:spPr>
+          <a:xfrm>
+            <a:off x="822960" y="1097280"/>
+            <a:ext cx="10515600" cy="5212080"/>
+          </a:xfrm>
+          <a:prstGeom prst="rect">
+            <a:avLst/>
+          </a:prstGeom>
+        </p:spPr>
+      </p:pic>
+    </p:spTree>
+  </p:cSld>
+  <p:clrMapOvr>
+    <a:masterClrMapping/>
+  </p:clrMapOvr>
+</p:sld>
+</file>
+
+<file path=ppt/slides/slide12.xml><?xml version="1.0" encoding="utf-8"?>
+<p:sld xmlns:a="http://schemas.openxmlformats.org/drawingml/2006/main" xmlns:p="http://schemas.openxmlformats.org/presentationml/2006/main" xmlns:r="http://schemas.openxmlformats.org/officeDocument/2006/relationships">
+  <p:cSld>
+    <p:spTree>
+      <p:nvGrpSpPr>
+        <p:cNvPr id="1" name=""/>
+        <p:cNvGrpSpPr/>
+        <p:nvPr/>
+      </p:nvGrpSpPr>
+      <p:grpSpPr/>
+      <p:sp>
+        <p:nvSpPr>
+          <p:cNvPr id="2" name="TextBox 1"/>
+          <p:cNvSpPr txBox="1"/>
+          <p:nvPr/>
+        </p:nvSpPr>
+        <p:spPr>
+          <a:xfrm>
+            <a:off x="502920" y="365760"/>
+            <a:ext cx="10972800" cy="457200"/>
+          </a:xfrm>
+          <a:prstGeom prst="rect">
+            <a:avLst/>
+          </a:prstGeom>
+          <a:noFill/>
+        </p:spPr>
+        <p:txBody>
+          <a:bodyPr wrap="none">
+            <a:spAutoFit/>
+          </a:bodyPr>
+          <a:lstStyle/>
+          <a:p>
+            <a:r>
+              <a:rPr sz="2800" b="1">
+                <a:solidFill>
+                  <a:srgbClr val="1F2933"/>
+                </a:solidFill>
+                <a:latin typeface="Arial"/>
+              </a:rPr>
+              <a:t>Hybrid Decision Matrix</a:t>
+            </a:r>
+          </a:p>
+        </p:txBody>
+      </p:sp>
+      <p:pic>
+        <p:nvPicPr>
+          <p:cNvPr id="3" name="Picture 2" descr="hybrid_decision_matrix.png"/>
+          <p:cNvPicPr>
+            <a:picLocks noChangeAspect="1"/>
+          </p:cNvPicPr>
+          <p:nvPr/>
+        </p:nvPicPr>
+        <p:blipFill>
+          <a:blip r:embed="rId2"/>
+          <a:stretch>
+            <a:fillRect/>
+          </a:stretch>
+        </p:blipFill>
+        <p:spPr>
+          <a:xfrm>
+            <a:off x="822960" y="1097280"/>
+            <a:ext cx="10515600" cy="5212080"/>
+          </a:xfrm>
+          <a:prstGeom prst="rect">
+            <a:avLst/>
+          </a:prstGeom>
+        </p:spPr>
+      </p:pic>
+    </p:spTree>
+  </p:cSld>
+  <p:clrMapOvr>
+    <a:masterClrMapping/>
+  </p:clrMapOvr>
+</p:sld>
+</file>
+
+<file path=ppt/slides/slide13.xml><?xml version="1.0" encoding="utf-8"?>
+<p:sld xmlns:a="http://schemas.openxmlformats.org/drawingml/2006/main" xmlns:p="http://schemas.openxmlformats.org/presentationml/2006/main" xmlns:r="http://schemas.openxmlformats.org/officeDocument/2006/relationships">
+  <p:cSld>
+    <p:spTree>
+      <p:nvGrpSpPr>
+        <p:cNvPr id="1" name=""/>
+        <p:cNvGrpSpPr/>
+        <p:nvPr/>
+      </p:nvGrpSpPr>
+      <p:grpSpPr/>
+      <p:sp>
+        <p:nvSpPr>
+          <p:cNvPr id="2" name="TextBox 1"/>
+          <p:cNvSpPr txBox="1"/>
+          <p:nvPr/>
+        </p:nvSpPr>
+        <p:spPr>
+          <a:xfrm>
+            <a:off x="502920" y="365760"/>
+            <a:ext cx="10972800" cy="457200"/>
+          </a:xfrm>
+          <a:prstGeom prst="rect">
+            <a:avLst/>
+          </a:prstGeom>
+          <a:noFill/>
+        </p:spPr>
+        <p:txBody>
+          <a:bodyPr wrap="none">
+            <a:spAutoFit/>
+          </a:bodyPr>
+          <a:lstStyle/>
+          <a:p>
+            <a:r>
+              <a:rPr sz="2800" b="1">
+                <a:solidFill>
+                  <a:srgbClr val="1F2933"/>
+                </a:solidFill>
+                <a:latin typeface="Arial"/>
+              </a:rPr>
+              <a:t>Temporal Stability</a:t>
+            </a:r>
+          </a:p>
+        </p:txBody>
+      </p:sp>
+      <p:pic>
+        <p:nvPicPr>
+          <p:cNvPr id="3" name="Picture 2" descr="monthly_stability_backtest.png"/>
+          <p:cNvPicPr>
+            <a:picLocks noChangeAspect="1"/>
+          </p:cNvPicPr>
+          <p:nvPr/>
+        </p:nvPicPr>
+        <p:blipFill>
+          <a:blip r:embed="rId2"/>
+          <a:stretch>
+            <a:fillRect/>
+          </a:stretch>
+        </p:blipFill>
+        <p:spPr>
+          <a:xfrm>
+            <a:off x="822960" y="1097280"/>
+            <a:ext cx="10515600" cy="5212080"/>
+          </a:xfrm>
+          <a:prstGeom prst="rect">
+            <a:avLst/>
+          </a:prstGeom>
+        </p:spPr>
+      </p:pic>
+    </p:spTree>
+  </p:cSld>
+  <p:clrMapOvr>
+    <a:masterClrMapping/>
+  </p:clrMapOvr>
+</p:sld>
+</file>
+
+<file path=ppt/slides/slide14.xml><?xml version="1.0" encoding="utf-8"?>
+<p:sld xmlns:a="http://schemas.openxmlformats.org/drawingml/2006/main" xmlns:p="http://schemas.openxmlformats.org/presentationml/2006/main" xmlns:r="http://schemas.openxmlformats.org/officeDocument/2006/relationships">
+  <p:cSld>
+    <p:spTree>
+      <p:nvGrpSpPr>
+        <p:cNvPr id="1" name=""/>
+        <p:cNvGrpSpPr/>
+        <p:nvPr/>
+      </p:nvGrpSpPr>
+      <p:grpSpPr/>
+      <p:sp>
+        <p:nvSpPr>
+          <p:cNvPr id="2" name="TextBox 1"/>
+          <p:cNvSpPr txBox="1"/>
+          <p:nvPr/>
+        </p:nvSpPr>
+        <p:spPr>
+          <a:xfrm>
+            <a:off x="502920" y="365760"/>
+            <a:ext cx="10972800" cy="457200"/>
+          </a:xfrm>
+          <a:prstGeom prst="rect">
+            <a:avLst/>
+          </a:prstGeom>
+          <a:noFill/>
+        </p:spPr>
+        <p:txBody>
+          <a:bodyPr wrap="none">
+            <a:spAutoFit/>
+          </a:bodyPr>
+          <a:lstStyle/>
+          <a:p>
+            <a:r>
+              <a:rPr sz="2800" b="1">
+                <a:solidFill>
+                  <a:srgbClr val="1F2933"/>
+                </a:solidFill>
+                <a:latin typeface="Arial"/>
+              </a:rPr>
+              <a:t>SHAP Explainability</a:t>
+            </a:r>
+          </a:p>
+        </p:txBody>
+      </p:sp>
+      <p:pic>
+        <p:nvPicPr>
+          <p:cNvPr id="3" name="Picture 2" descr="shap_feature_importance.png"/>
+          <p:cNvPicPr>
+            <a:picLocks noChangeAspect="1"/>
+          </p:cNvPicPr>
+          <p:nvPr/>
+        </p:nvPicPr>
+        <p:blipFill>
+          <a:blip r:embed="rId2"/>
+          <a:stretch>
+            <a:fillRect/>
+          </a:stretch>
+        </p:blipFill>
+        <p:spPr>
+          <a:xfrm>
+            <a:off x="822960" y="1097280"/>
+            <a:ext cx="10515600" cy="5212080"/>
+          </a:xfrm>
+          <a:prstGeom prst="rect">
+            <a:avLst/>
+          </a:prstGeom>
+        </p:spPr>
+      </p:pic>
+    </p:spTree>
+  </p:cSld>
+  <p:clrMapOvr>
+    <a:masterClrMapping/>
+  </p:clrMapOvr>
+</p:sld>
+</file>
+
 <file path=ppt/slides/slide2.xml><?xml version="1.0" encoding="utf-8"?>
 <p:sld xmlns:a="http://schemas.openxmlformats.org/drawingml/2006/main" xmlns:p="http://schemas.openxmlformats.org/presentationml/2006/main" xmlns:r="http://schemas.openxmlformats.org/officeDocument/2006/relationships">
   <p:cSld>
@@ -3513,7 +3898,7 @@
                 </a:solidFill>
                 <a:latin typeface="Arial"/>
               </a:rPr>
-              <a:t>Data -&gt; baseline -&gt; rules -&gt; weak labels -&gt; supervised prevention model -&gt; SHAP/xAI.</a:t>
+              <a:t>4 phases, 11 steps: foundation -&gt; EDA/labels -&gt; ML/matrix -&gt; dashboard/xAI.</a:t>
             </a:r>
           </a:p>
         </p:txBody>
@@ -3546,7 +3931,7 @@
               </a:defRPr>
             </a:pPr>
             <a:r>
-              <a:t>Customer 360 baseline by Transactional, Financial, Environmental and Behavioral groups</a:t>
+              <a:t>Phase 1: clean data, four baseline groups, Customer 360 rolling 30/60/90 days</a:t>
             </a:r>
           </a:p>
           <a:p>
@@ -3556,7 +3941,7 @@
               </a:defRPr>
             </a:pPr>
             <a:r>
-              <a:t>Rolling 30/60/90-day features plus IQR thresholds</a:t>
+              <a:t>Phase 2: strategic EDA, IQR thresholding, dynamic root-cause rules, weak labels</a:t>
             </a:r>
           </a:p>
           <a:p>
@@ -3566,7 +3951,7 @@
               </a:defRPr>
             </a:pPr>
             <a:r>
-              <a:t>Rule-derived weak labels train the supervised prevention model</a:t>
+              <a:t>Phase 3: RandomForest prevention model and Rule + ML action matrix</a:t>
             </a:r>
           </a:p>
           <a:p>
@@ -3576,7 +3961,7 @@
               </a:defRPr>
             </a:pPr>
             <a:r>
-              <a:t>Hybrid matrix creates human-readable recommended actions</a:t>
+              <a:t>Phase 4: dashboard, protected amount, SHAP xAI and natural-language reason codes</a:t>
             </a:r>
           </a:p>
         </p:txBody>
@@ -3671,7 +4056,7 @@
                 </a:solidFill>
                 <a:latin typeface="Arial"/>
               </a:rPr>
-              <a:t>Key Metrics</a:t>
+              <a:t>Data Insights</a:t>
             </a:r>
           </a:p>
         </p:txBody>
@@ -3705,7 +4090,7 @@
                 </a:solidFill>
                 <a:latin typeface="Arial"/>
               </a:rPr>
-              <a:t>1,418,030 transactions scored; 402,266 High/Critical.</a:t>
+              <a:t>EDA is now driven by risk lift, heatmaps, and interaction charts.</a:t>
             </a:r>
           </a:p>
         </p:txBody>
@@ -3738,7 +4123,7 @@
               </a:defRPr>
             </a:pPr>
             <a:r>
-              <a:t>Prevention coverage vs weak labels: 100.0%</a:t>
+              <a:t>Root-cause x hybrid-decision heatmap</a:t>
             </a:r>
           </a:p>
           <a:p>
@@ -3748,7 +4133,7 @@
               </a:defRPr>
             </a:pPr>
             <a:r>
-              <a:t>False-positive rate at high threshold: 0.00%</a:t>
+              <a:t>IQR breach lift versus normal baseline</a:t>
             </a:r>
           </a:p>
           <a:p>
@@ -3758,7 +4143,7 @@
               </a:defRPr>
             </a:pPr>
             <a:r>
-              <a:t>Confusion matrix and protected amount are reported for business impact, not only model accuracy.</a:t>
+              <a:t>Time, network and Customer 360 risk maps</a:t>
             </a:r>
           </a:p>
         </p:txBody>
@@ -3783,14 +4168,57 @@
       <p:grpSpPr/>
       <p:sp>
         <p:nvSpPr>
-          <p:cNvPr id="2" name="TextBox 1"/>
+          <p:cNvPr id="2" name="Rectangle 1"/>
+          <p:cNvSpPr/>
+          <p:nvPr/>
+        </p:nvSpPr>
+        <p:spPr>
+          <a:xfrm>
+            <a:off x="0" y="0"/>
+            <a:ext cx="12191695" cy="146304"/>
+          </a:xfrm>
+          <a:prstGeom prst="rect">
+            <a:avLst/>
+          </a:prstGeom>
+          <a:solidFill>
+            <a:srgbClr val="2F6B8F"/>
+          </a:solidFill>
+          <a:ln>
+            <a:noFill/>
+          </a:ln>
+        </p:spPr>
+        <p:style>
+          <a:lnRef idx="1">
+            <a:schemeClr val="accent1"/>
+          </a:lnRef>
+          <a:fillRef idx="3">
+            <a:schemeClr val="accent1"/>
+          </a:fillRef>
+          <a:effectRef idx="2">
+            <a:schemeClr val="accent1"/>
+          </a:effectRef>
+          <a:fontRef idx="minor">
+            <a:schemeClr val="lt1"/>
+          </a:fontRef>
+        </p:style>
+        <p:txBody>
+          <a:bodyPr rtlCol="0" anchor="ctr"/>
+          <a:lstStyle/>
+          <a:p>
+            <a:pPr algn="ctr"/>
+          </a:p>
+        </p:txBody>
+      </p:sp>
+      <p:sp>
+        <p:nvSpPr>
+          <p:cNvPr id="3" name="TextBox 2"/>
           <p:cNvSpPr txBox="1"/>
           <p:nvPr/>
         </p:nvSpPr>
         <p:spPr>
           <a:xfrm>
-            <a:off x="502920" y="365760"/>
-            <a:ext cx="10972800" cy="457200"/>
+            <a:off x="502920" y="502920"/>
+            <a:ext cx="10972800" cy="502920"/>
           </a:xfrm>
           <a:prstGeom prst="rect">
             <a:avLst/>
@@ -3804,41 +4232,104 @@
           <a:lstStyle/>
           <a:p>
             <a:r>
-              <a:rPr sz="2800" b="1">
+              <a:rPr sz="3000" b="1">
                 <a:solidFill>
                   <a:srgbClr val="1F2933"/>
                 </a:solidFill>
                 <a:latin typeface="Arial"/>
               </a:rPr>
-              <a:t>Root-Cause Review Queue</a:t>
-            </a:r>
-          </a:p>
-        </p:txBody>
-      </p:sp>
-      <p:pic>
-        <p:nvPicPr>
-          <p:cNvPr id="3" name="Picture 2" descr="root_cause_high_critical.png"/>
-          <p:cNvPicPr>
-            <a:picLocks noChangeAspect="1"/>
-          </p:cNvPicPr>
+              <a:t>Key Metrics</a:t>
+            </a:r>
+          </a:p>
+        </p:txBody>
+      </p:sp>
+      <p:sp>
+        <p:nvSpPr>
+          <p:cNvPr id="4" name="TextBox 3"/>
+          <p:cNvSpPr txBox="1"/>
           <p:nvPr/>
-        </p:nvPicPr>
-        <p:blipFill>
-          <a:blip r:embed="rId2"/>
-          <a:stretch>
-            <a:fillRect/>
-          </a:stretch>
-        </p:blipFill>
-        <p:spPr>
-          <a:xfrm>
-            <a:off x="822960" y="1097280"/>
-            <a:ext cx="10515600" cy="5212080"/>
+        </p:nvSpPr>
+        <p:spPr>
+          <a:xfrm>
+            <a:off x="530352" y="1051560"/>
+            <a:ext cx="10972800" cy="411480"/>
           </a:xfrm>
           <a:prstGeom prst="rect">
             <a:avLst/>
           </a:prstGeom>
-        </p:spPr>
-      </p:pic>
+          <a:noFill/>
+        </p:spPr>
+        <p:txBody>
+          <a:bodyPr wrap="none">
+            <a:spAutoFit/>
+          </a:bodyPr>
+          <a:lstStyle/>
+          <a:p>
+            <a:r>
+              <a:rPr sz="1600" b="0">
+                <a:solidFill>
+                  <a:srgbClr val="52606D"/>
+                </a:solidFill>
+                <a:latin typeface="Arial"/>
+              </a:rPr>
+              <a:t>1,418,030 transactions scored; 109,155 High/Critical.</a:t>
+            </a:r>
+          </a:p>
+        </p:txBody>
+      </p:sp>
+      <p:sp>
+        <p:nvSpPr>
+          <p:cNvPr id="5" name="TextBox 4"/>
+          <p:cNvSpPr txBox="1"/>
+          <p:nvPr/>
+        </p:nvSpPr>
+        <p:spPr>
+          <a:xfrm>
+            <a:off x="685800" y="1828800"/>
+            <a:ext cx="10698480" cy="3840480"/>
+          </a:xfrm>
+          <a:prstGeom prst="rect">
+            <a:avLst/>
+          </a:prstGeom>
+          <a:noFill/>
+        </p:spPr>
+        <p:txBody>
+          <a:bodyPr wrap="none">
+            <a:spAutoFit/>
+          </a:bodyPr>
+          <a:lstStyle/>
+          <a:p>
+            <a:pPr>
+              <a:defRPr sz="2100">
+                <a:latin typeface="Arial"/>
+              </a:defRPr>
+            </a:pPr>
+            <a:r>
+              <a:t>Prevention coverage vs weak labels: 100.0%</a:t>
+            </a:r>
+          </a:p>
+          <a:p>
+            <a:pPr>
+              <a:defRPr sz="2100">
+                <a:latin typeface="Arial"/>
+              </a:defRPr>
+            </a:pPr>
+            <a:r>
+              <a:t>False-positive rate at high threshold: 0.00%</a:t>
+            </a:r>
+          </a:p>
+          <a:p>
+            <a:pPr>
+              <a:defRPr sz="2100">
+                <a:latin typeface="Arial"/>
+              </a:defRPr>
+            </a:pPr>
+            <a:r>
+              <a:t>Confusion matrix and protected amount are reported for business impact, not only model accuracy.</a:t>
+            </a:r>
+          </a:p>
+        </p:txBody>
+      </p:sp>
     </p:spTree>
   </p:cSld>
   <p:clrMapOvr>
@@ -3886,14 +4377,14 @@
                 </a:solidFill>
                 <a:latin typeface="Arial"/>
               </a:rPr>
-              <a:t>Customer 360 Rolling Baseline</a:t>
+              <a:t>Root-Cause x Hybrid Matrix</a:t>
             </a:r>
           </a:p>
         </p:txBody>
       </p:sp>
       <p:pic>
         <p:nvPicPr>
-          <p:cNvPr id="3" name="Picture 2" descr="rolling_window_baseline.png"/>
+          <p:cNvPr id="3" name="Picture 2" descr="root_cause_hybrid_heatmap.png"/>
           <p:cNvPicPr>
             <a:picLocks noChangeAspect="1"/>
           </p:cNvPicPr>
@@ -3962,14 +4453,14 @@
                 </a:solidFill>
                 <a:latin typeface="Arial"/>
               </a:rPr>
-              <a:t>Hybrid Decision Matrix</a:t>
+              <a:t>IQR Breach Lift</a:t>
             </a:r>
           </a:p>
         </p:txBody>
       </p:sp>
       <p:pic>
         <p:nvPicPr>
-          <p:cNvPr id="3" name="Picture 2" descr="hybrid_decision_matrix.png"/>
+          <p:cNvPr id="3" name="Picture 2" descr="iqr_breach_lift.png"/>
           <p:cNvPicPr>
             <a:picLocks noChangeAspect="1"/>
           </p:cNvPicPr>
@@ -4038,14 +4529,14 @@
                 </a:solidFill>
                 <a:latin typeface="Arial"/>
               </a:rPr>
-              <a:t>Temporal Stability</a:t>
+              <a:t>Time Risk Heatmap</a:t>
             </a:r>
           </a:p>
         </p:txBody>
       </p:sp>
       <p:pic>
         <p:nvPicPr>
-          <p:cNvPr id="3" name="Picture 2" descr="monthly_stability_backtest.png"/>
+          <p:cNvPr id="3" name="Picture 2" descr="time_risk_heatmap.png"/>
           <p:cNvPicPr>
             <a:picLocks noChangeAspect="1"/>
           </p:cNvPicPr>
@@ -4114,14 +4605,14 @@
                 </a:solidFill>
                 <a:latin typeface="Arial"/>
               </a:rPr>
-              <a:t>SHAP Explainability</a:t>
+              <a:t>Network Exposure</a:t>
             </a:r>
           </a:p>
         </p:txBody>
       </p:sp>
       <p:pic>
         <p:nvPicPr>
-          <p:cNvPr id="3" name="Picture 2" descr="shap_feature_importance.png"/>
+          <p:cNvPr id="3" name="Picture 2" descr="network_exposure_bubble.png"/>
           <p:cNvPicPr>
             <a:picLocks noChangeAspect="1"/>
           </p:cNvPicPr>

</xml_diff>